<commit_message>
fix: restore input templates and disable destructive cleanup
</commit_message>
<xml_diff>
--- a/report/2026_06_08_competitive_report.pptx
+++ b/report/2026_06_08_competitive_report.pptx
@@ -4353,111 +4353,7 @@
             <a:spAutoFit/>
           </a:bodyPr>
           <a:lstStyle/>
-          <a:p>
-            <a:pPr>
-              <a:spcAft>
-                <a:spcPts val="1400"/>
-              </a:spcAft>
-              <a:defRPr sz="1400">
-                <a:solidFill>
-                  <a:srgbClr val="1E1E1E"/>
-                </a:solidFill>
-              </a:defRPr>
-            </a:pPr>
-            <a:r>
-              <a:t>*   1. ヤマダストアーの布陣：</a:t>
-            </a:r>
-          </a:p>
-          <a:p>
-            <a:pPr>
-              <a:spcAft>
-                <a:spcPts val="1400"/>
-              </a:spcAft>
-              <a:defRPr sz="1400">
-                <a:solidFill>
-                  <a:srgbClr val="1E1E1E"/>
-                </a:solidFill>
-              </a:defRPr>
-            </a:pPr>
-            <a:r>
-              <a:t>*   大阪梅田店は大丸梅田店への出店であり、キタエリアの超広域から顧客を集めるパワーを持ちます。JR大阪駅改札からも至近距離に位置し、いかりJR大阪店との超至近距離でのプレミアム食材競争が発生します。</a:t>
-            </a:r>
-          </a:p>
-          <a:p>
-            <a:pPr>
-              <a:spcAft>
-                <a:spcPts val="1400"/>
-              </a:spcAft>
-              <a:defRPr sz="1400">
-                <a:solidFill>
-                  <a:srgbClr val="1E1E1E"/>
-                </a:solidFill>
-              </a:defRPr>
-            </a:pPr>
-            <a:r>
-              <a:t>*   宝塚店は宝塚市南部の伊孑志エリア（武庫川右岸）に位置し、武庫川を挟んですぐの「いかり宝塚店」および「いかり逆瀬川店」を完全に狙い撃ちする位置関係にあります。</a:t>
-            </a:r>
-          </a:p>
-          <a:p>
-            <a:pPr>
-              <a:spcAft>
-                <a:spcPts val="1400"/>
-              </a:spcAft>
-              <a:defRPr sz="1400">
-                <a:solidFill>
-                  <a:srgbClr val="1E1E1E"/>
-                </a:solidFill>
-              </a:defRPr>
-            </a:pPr>
-            <a:r>
-              <a:t>*   2. オーケーの市街地攻勢：</a:t>
-            </a:r>
-          </a:p>
-          <a:p>
-            <a:pPr>
-              <a:spcAft>
-                <a:spcPts val="1400"/>
-              </a:spcAft>
-              <a:defRPr sz="1400">
-                <a:solidFill>
-                  <a:srgbClr val="1E1E1E"/>
-                </a:solidFill>
-              </a:defRPr>
-            </a:pPr>
-            <a:r>
-              <a:t>*   下新庄店は、神崎川近くの人口密集地へ出店します。周辺には鉄道網も発達しており、広域からの車・電車の来店を吸収する立地です。</a:t>
-            </a:r>
-          </a:p>
-          <a:p>
-            <a:pPr>
-              <a:spcAft>
-                <a:spcPts val="1400"/>
-              </a:spcAft>
-              <a:defRPr sz="1400">
-                <a:solidFill>
-                  <a:srgbClr val="1E1E1E"/>
-                </a:solidFill>
-              </a:defRPr>
-            </a:pPr>
-            <a:r>
-              <a:t>*   3. 阪急オアシスの駅直結性：</a:t>
-            </a:r>
-          </a:p>
-          <a:p>
-            <a:pPr>
-              <a:spcAft>
-                <a:spcPts val="1400"/>
-              </a:spcAft>
-              <a:defRPr sz="1400">
-                <a:solidFill>
-                  <a:srgbClr val="1E1E1E"/>
-                </a:solidFill>
-              </a:defRPr>
-            </a:pPr>
-            <a:r>
-              <a:t>*   豊中駅前店はエトレとよなか地下という超一等地であり、いかり豊中店（駅北側）と豊中駅を挟んで対峙する関係です。今回の改装で店舗魅力がさらに向上します。</a:t>
-            </a:r>
-          </a:p>
+          <a:p/>
         </p:txBody>
       </p:sp>
     </p:spTree>

</xml_diff>

<commit_message>
fix: resolve map analysis parsing issue and regenerate report and map files
</commit_message>
<xml_diff>
--- a/report/2026_06_08_competitive_report.pptx
+++ b/report/2026_06_08_competitive_report.pptx
@@ -4353,7 +4353,111 @@
             <a:spAutoFit/>
           </a:bodyPr>
           <a:lstStyle/>
-          <a:p/>
+          <a:p>
+            <a:pPr>
+              <a:spcAft>
+                <a:spcPts val="1400"/>
+              </a:spcAft>
+              <a:defRPr sz="1400">
+                <a:solidFill>
+                  <a:srgbClr val="1E1E1E"/>
+                </a:solidFill>
+              </a:defRPr>
+            </a:pPr>
+            <a:r>
+              <a:t>*   1. ヤマダストアーの布陣：</a:t>
+            </a:r>
+          </a:p>
+          <a:p>
+            <a:pPr>
+              <a:spcAft>
+                <a:spcPts val="1400"/>
+              </a:spcAft>
+              <a:defRPr sz="1400">
+                <a:solidFill>
+                  <a:srgbClr val="1E1E1E"/>
+                </a:solidFill>
+              </a:defRPr>
+            </a:pPr>
+            <a:r>
+              <a:t>*   大阪梅田店は大丸梅田店への出店であり、キタエリアの超広域から顧客を集めるパワーを持ちます。JR大阪駅改札からも至近距離に位置し、いかりJR大阪店との超至近距離でのプレミアム食材競争が発生します。</a:t>
+            </a:r>
+          </a:p>
+          <a:p>
+            <a:pPr>
+              <a:spcAft>
+                <a:spcPts val="1400"/>
+              </a:spcAft>
+              <a:defRPr sz="1400">
+                <a:solidFill>
+                  <a:srgbClr val="1E1E1E"/>
+                </a:solidFill>
+              </a:defRPr>
+            </a:pPr>
+            <a:r>
+              <a:t>*   宝塚店は宝塚市南部の伊孑志エリア（武庫川右岸）に位置し、武庫川を挟んですぐの「いかり宝塚店」および「いかり逆瀬川店」を完全に狙い撃ちする位置関係にあります。</a:t>
+            </a:r>
+          </a:p>
+          <a:p>
+            <a:pPr>
+              <a:spcAft>
+                <a:spcPts val="1400"/>
+              </a:spcAft>
+              <a:defRPr sz="1400">
+                <a:solidFill>
+                  <a:srgbClr val="1E1E1E"/>
+                </a:solidFill>
+              </a:defRPr>
+            </a:pPr>
+            <a:r>
+              <a:t>*   2. オーケーの市街地攻勢：</a:t>
+            </a:r>
+          </a:p>
+          <a:p>
+            <a:pPr>
+              <a:spcAft>
+                <a:spcPts val="1400"/>
+              </a:spcAft>
+              <a:defRPr sz="1400">
+                <a:solidFill>
+                  <a:srgbClr val="1E1E1E"/>
+                </a:solidFill>
+              </a:defRPr>
+            </a:pPr>
+            <a:r>
+              <a:t>*   下新庄店は、神崎川近くの人口密集地へ出店します。周辺には鉄道網も発達しており、広域からの車・電車の来店を吸収する立地です。</a:t>
+            </a:r>
+          </a:p>
+          <a:p>
+            <a:pPr>
+              <a:spcAft>
+                <a:spcPts val="1400"/>
+              </a:spcAft>
+              <a:defRPr sz="1400">
+                <a:solidFill>
+                  <a:srgbClr val="1E1E1E"/>
+                </a:solidFill>
+              </a:defRPr>
+            </a:pPr>
+            <a:r>
+              <a:t>*   3. 阪急オアシスの駅直結性：</a:t>
+            </a:r>
+          </a:p>
+          <a:p>
+            <a:pPr>
+              <a:spcAft>
+                <a:spcPts val="1400"/>
+              </a:spcAft>
+              <a:defRPr sz="1400">
+                <a:solidFill>
+                  <a:srgbClr val="1E1E1E"/>
+                </a:solidFill>
+              </a:defRPr>
+            </a:pPr>
+            <a:r>
+              <a:t>*   豊中駅前店はエトレとよなか地下という超一等地であり、いかり豊中店（駅北側）と豊中駅を挟んで対峙する関係です。今回の改装で店舗魅力がさらに向上します。</a:t>
+            </a:r>
+          </a:p>
         </p:txBody>
       </p:sp>
     </p:spTree>

</xml_diff>